<commit_message>
Polish release documentation and presentation
</commit_message>
<xml_diff>
--- a/docs/SwimCRM_client_presentation_ru.pptx
+++ b/docs/SwimCRM_client_presentation_ru.pptx
@@ -3146,8 +3146,8 @@
           <a:noFill/>
         </p:spPr>
         <p:txBody>
-          <a:bodyPr wrap="none" lIns="27432" rIns="27432" tIns="18288" bIns="18288" anchor="t">
-            <a:spAutoFit/>
+          <a:bodyPr wrap="square" lIns="27432" rIns="27432" tIns="18288" bIns="18288" anchor="t">
+            <a:normAutofit/>
           </a:bodyPr>
           <a:lstStyle/>
           <a:p>
@@ -3180,8 +3180,8 @@
           <a:noFill/>
         </p:spPr>
         <p:txBody>
-          <a:bodyPr wrap="none" lIns="27432" rIns="27432" tIns="18288" bIns="18288" anchor="t">
-            <a:spAutoFit/>
+          <a:bodyPr wrap="square" lIns="27432" rIns="27432" tIns="18288" bIns="18288" anchor="t">
+            <a:normAutofit/>
           </a:bodyPr>
           <a:lstStyle/>
           <a:p>
@@ -3214,8 +3214,8 @@
           <a:noFill/>
         </p:spPr>
         <p:txBody>
-          <a:bodyPr wrap="none" lIns="27432" rIns="27432" tIns="18288" bIns="18288" anchor="t">
-            <a:spAutoFit/>
+          <a:bodyPr wrap="square" lIns="27432" rIns="27432" tIns="18288" bIns="18288" anchor="t">
+            <a:normAutofit/>
           </a:bodyPr>
           <a:lstStyle/>
           <a:p>
@@ -3274,8 +3274,8 @@
           <a:noFill/>
         </p:spPr>
         <p:txBody>
-          <a:bodyPr wrap="none" lIns="27432" rIns="27432" tIns="18288" bIns="18288" anchor="t">
-            <a:spAutoFit/>
+          <a:bodyPr wrap="square" lIns="27432" rIns="27432" tIns="18288" bIns="18288" anchor="t">
+            <a:normAutofit/>
           </a:bodyPr>
           <a:lstStyle/>
           <a:p>
@@ -3308,8 +3308,8 @@
           <a:noFill/>
         </p:spPr>
         <p:txBody>
-          <a:bodyPr wrap="none" lIns="27432" rIns="27432" tIns="18288" bIns="18288" anchor="t">
-            <a:spAutoFit/>
+          <a:bodyPr wrap="square" lIns="27432" rIns="27432" tIns="18288" bIns="18288" anchor="t">
+            <a:normAutofit/>
           </a:bodyPr>
           <a:lstStyle/>
           <a:p>
@@ -3384,8 +3384,8 @@
         </p:blipFill>
         <p:spPr>
           <a:xfrm>
-            <a:off x="6172200" y="1143000"/>
-            <a:ext cx="5349240" cy="3017520"/>
+            <a:off x="6263640" y="1078992"/>
+            <a:ext cx="5074920" cy="2852928"/>
           </a:xfrm>
           <a:prstGeom prst="rect">
             <a:avLst/>
@@ -3400,7 +3400,7 @@
         </p:nvSpPr>
         <p:spPr>
           <a:xfrm>
-            <a:off x="731520" y="1335024"/>
+            <a:off x="731520" y="1243584"/>
             <a:ext cx="100584" cy="100584"/>
           </a:xfrm>
           <a:prstGeom prst="ellipse">
@@ -3443,8 +3443,8 @@
         </p:nvSpPr>
         <p:spPr>
           <a:xfrm>
-            <a:off x="960120" y="1234440"/>
-            <a:ext cx="4754880" cy="530352"/>
+            <a:off x="960120" y="1143000"/>
+            <a:ext cx="4846320" cy="658368"/>
           </a:xfrm>
           <a:prstGeom prst="rect">
             <a:avLst/>
@@ -3452,13 +3452,13 @@
           <a:noFill/>
         </p:spPr>
         <p:txBody>
-          <a:bodyPr wrap="none" lIns="27432" rIns="27432" tIns="18288" bIns="18288" anchor="t">
-            <a:spAutoFit/>
+          <a:bodyPr wrap="square" lIns="27432" rIns="27432" tIns="18288" bIns="18288" anchor="t">
+            <a:normAutofit/>
           </a:bodyPr>
           <a:lstStyle/>
           <a:p>
             <a:r>
-              <a:rPr sz="1400" b="0">
+              <a:rPr sz="1200" b="0">
                 <a:solidFill>
                   <a:srgbClr val="495461"/>
                 </a:solidFill>
@@ -3477,7 +3477,7 @@
         </p:nvSpPr>
         <p:spPr>
           <a:xfrm>
-            <a:off x="731520" y="1956816"/>
+            <a:off x="731520" y="2048256"/>
             <a:ext cx="100584" cy="100584"/>
           </a:xfrm>
           <a:prstGeom prst="ellipse">
@@ -3520,8 +3520,8 @@
         </p:nvSpPr>
         <p:spPr>
           <a:xfrm>
-            <a:off x="960120" y="1856232"/>
-            <a:ext cx="4754880" cy="530352"/>
+            <a:off x="960120" y="1947672"/>
+            <a:ext cx="4846320" cy="658368"/>
           </a:xfrm>
           <a:prstGeom prst="rect">
             <a:avLst/>
@@ -3529,13 +3529,13 @@
           <a:noFill/>
         </p:spPr>
         <p:txBody>
-          <a:bodyPr wrap="none" lIns="27432" rIns="27432" tIns="18288" bIns="18288" anchor="t">
-            <a:spAutoFit/>
+          <a:bodyPr wrap="square" lIns="27432" rIns="27432" tIns="18288" bIns="18288" anchor="t">
+            <a:normAutofit/>
           </a:bodyPr>
           <a:lstStyle/>
           <a:p>
             <a:r>
-              <a:rPr sz="1400" b="0">
+              <a:rPr sz="1200" b="0">
                 <a:solidFill>
                   <a:srgbClr val="495461"/>
                 </a:solidFill>
@@ -3554,7 +3554,7 @@
         </p:nvSpPr>
         <p:spPr>
           <a:xfrm>
-            <a:off x="731520" y="2578608"/>
+            <a:off x="731520" y="2852928"/>
             <a:ext cx="100584" cy="100584"/>
           </a:xfrm>
           <a:prstGeom prst="ellipse">
@@ -3597,8 +3597,8 @@
         </p:nvSpPr>
         <p:spPr>
           <a:xfrm>
-            <a:off x="960120" y="2478024"/>
-            <a:ext cx="4754880" cy="530352"/>
+            <a:off x="960120" y="2752344"/>
+            <a:ext cx="4846320" cy="658368"/>
           </a:xfrm>
           <a:prstGeom prst="rect">
             <a:avLst/>
@@ -3606,13 +3606,13 @@
           <a:noFill/>
         </p:spPr>
         <p:txBody>
-          <a:bodyPr wrap="none" lIns="27432" rIns="27432" tIns="18288" bIns="18288" anchor="t">
-            <a:spAutoFit/>
+          <a:bodyPr wrap="square" lIns="27432" rIns="27432" tIns="18288" bIns="18288" anchor="t">
+            <a:normAutofit/>
           </a:bodyPr>
           <a:lstStyle/>
           <a:p>
             <a:r>
-              <a:rPr sz="1400" b="0">
+              <a:rPr sz="1200" b="0">
                 <a:solidFill>
                   <a:srgbClr val="495461"/>
                 </a:solidFill>
@@ -3640,8 +3640,8 @@
           <a:noFill/>
         </p:spPr>
         <p:txBody>
-          <a:bodyPr wrap="none" lIns="27432" rIns="27432" tIns="18288" bIns="18288" anchor="t">
-            <a:spAutoFit/>
+          <a:bodyPr wrap="square" lIns="27432" rIns="27432" tIns="18288" bIns="18288" anchor="t">
+            <a:normAutofit/>
           </a:bodyPr>
           <a:lstStyle/>
           <a:p>
@@ -3701,8 +3701,8 @@
           <a:noFill/>
         </p:spPr>
         <p:txBody>
-          <a:bodyPr wrap="none" lIns="27432" rIns="27432" tIns="18288" bIns="18288" anchor="t">
-            <a:spAutoFit/>
+          <a:bodyPr wrap="square" lIns="27432" rIns="27432" tIns="18288" bIns="18288" anchor="t">
+            <a:normAutofit/>
           </a:bodyPr>
           <a:lstStyle/>
           <a:p>
@@ -3735,8 +3735,8 @@
           <a:noFill/>
         </p:spPr>
         <p:txBody>
-          <a:bodyPr wrap="none" lIns="27432" rIns="27432" tIns="18288" bIns="18288" anchor="t">
-            <a:spAutoFit/>
+          <a:bodyPr wrap="square" lIns="27432" rIns="27432" tIns="18288" bIns="18288" anchor="t">
+            <a:normAutofit/>
           </a:bodyPr>
           <a:lstStyle/>
           <a:p>
@@ -3811,8 +3811,8 @@
         </p:blipFill>
         <p:spPr>
           <a:xfrm>
-            <a:off x="6172200" y="1143000"/>
-            <a:ext cx="5349240" cy="3017520"/>
+            <a:off x="6263640" y="1078992"/>
+            <a:ext cx="5074920" cy="2852928"/>
           </a:xfrm>
           <a:prstGeom prst="rect">
             <a:avLst/>
@@ -3827,7 +3827,7 @@
         </p:nvSpPr>
         <p:spPr>
           <a:xfrm>
-            <a:off x="731520" y="1335024"/>
+            <a:off x="731520" y="1243584"/>
             <a:ext cx="100584" cy="100584"/>
           </a:xfrm>
           <a:prstGeom prst="ellipse">
@@ -3870,8 +3870,8 @@
         </p:nvSpPr>
         <p:spPr>
           <a:xfrm>
-            <a:off x="960120" y="1234440"/>
-            <a:ext cx="4754880" cy="530352"/>
+            <a:off x="960120" y="1143000"/>
+            <a:ext cx="4846320" cy="658368"/>
           </a:xfrm>
           <a:prstGeom prst="rect">
             <a:avLst/>
@@ -3879,13 +3879,13 @@
           <a:noFill/>
         </p:spPr>
         <p:txBody>
-          <a:bodyPr wrap="none" lIns="27432" rIns="27432" tIns="18288" bIns="18288" anchor="t">
-            <a:spAutoFit/>
+          <a:bodyPr wrap="square" lIns="27432" rIns="27432" tIns="18288" bIns="18288" anchor="t">
+            <a:normAutofit/>
           </a:bodyPr>
           <a:lstStyle/>
           <a:p>
             <a:r>
-              <a:rPr sz="1400" b="0">
+              <a:rPr sz="1200" b="0">
                 <a:solidFill>
                   <a:srgbClr val="495461"/>
                 </a:solidFill>
@@ -3904,7 +3904,7 @@
         </p:nvSpPr>
         <p:spPr>
           <a:xfrm>
-            <a:off x="731520" y="1956816"/>
+            <a:off x="731520" y="2048256"/>
             <a:ext cx="100584" cy="100584"/>
           </a:xfrm>
           <a:prstGeom prst="ellipse">
@@ -3947,8 +3947,8 @@
         </p:nvSpPr>
         <p:spPr>
           <a:xfrm>
-            <a:off x="960120" y="1856232"/>
-            <a:ext cx="4754880" cy="530352"/>
+            <a:off x="960120" y="1947672"/>
+            <a:ext cx="4846320" cy="658368"/>
           </a:xfrm>
           <a:prstGeom prst="rect">
             <a:avLst/>
@@ -3956,13 +3956,13 @@
           <a:noFill/>
         </p:spPr>
         <p:txBody>
-          <a:bodyPr wrap="none" lIns="27432" rIns="27432" tIns="18288" bIns="18288" anchor="t">
-            <a:spAutoFit/>
+          <a:bodyPr wrap="square" lIns="27432" rIns="27432" tIns="18288" bIns="18288" anchor="t">
+            <a:normAutofit/>
           </a:bodyPr>
           <a:lstStyle/>
           <a:p>
             <a:r>
-              <a:rPr sz="1400" b="0">
+              <a:rPr sz="1200" b="0">
                 <a:solidFill>
                   <a:srgbClr val="495461"/>
                 </a:solidFill>
@@ -3981,7 +3981,7 @@
         </p:nvSpPr>
         <p:spPr>
           <a:xfrm>
-            <a:off x="731520" y="2578608"/>
+            <a:off x="731520" y="2852928"/>
             <a:ext cx="100584" cy="100584"/>
           </a:xfrm>
           <a:prstGeom prst="ellipse">
@@ -4024,8 +4024,8 @@
         </p:nvSpPr>
         <p:spPr>
           <a:xfrm>
-            <a:off x="960120" y="2478024"/>
-            <a:ext cx="4754880" cy="530352"/>
+            <a:off x="960120" y="2752344"/>
+            <a:ext cx="4846320" cy="658368"/>
           </a:xfrm>
           <a:prstGeom prst="rect">
             <a:avLst/>
@@ -4033,13 +4033,13 @@
           <a:noFill/>
         </p:spPr>
         <p:txBody>
-          <a:bodyPr wrap="none" lIns="27432" rIns="27432" tIns="18288" bIns="18288" anchor="t">
-            <a:spAutoFit/>
+          <a:bodyPr wrap="square" lIns="27432" rIns="27432" tIns="18288" bIns="18288" anchor="t">
+            <a:normAutofit/>
           </a:bodyPr>
           <a:lstStyle/>
           <a:p>
             <a:r>
-              <a:rPr sz="1400" b="0">
+              <a:rPr sz="1200" b="0">
                 <a:solidFill>
                   <a:srgbClr val="495461"/>
                 </a:solidFill>
@@ -4067,8 +4067,8 @@
           <a:noFill/>
         </p:spPr>
         <p:txBody>
-          <a:bodyPr wrap="none" lIns="27432" rIns="27432" tIns="18288" bIns="18288" anchor="t">
-            <a:spAutoFit/>
+          <a:bodyPr wrap="square" lIns="27432" rIns="27432" tIns="18288" bIns="18288" anchor="t">
+            <a:normAutofit/>
           </a:bodyPr>
           <a:lstStyle/>
           <a:p>
@@ -4128,8 +4128,8 @@
           <a:noFill/>
         </p:spPr>
         <p:txBody>
-          <a:bodyPr wrap="none" lIns="27432" rIns="27432" tIns="18288" bIns="18288" anchor="t">
-            <a:spAutoFit/>
+          <a:bodyPr wrap="square" lIns="27432" rIns="27432" tIns="18288" bIns="18288" anchor="t">
+            <a:normAutofit/>
           </a:bodyPr>
           <a:lstStyle/>
           <a:p>
@@ -4162,8 +4162,8 @@
           <a:noFill/>
         </p:spPr>
         <p:txBody>
-          <a:bodyPr wrap="none" lIns="27432" rIns="27432" tIns="18288" bIns="18288" anchor="t">
-            <a:spAutoFit/>
+          <a:bodyPr wrap="square" lIns="27432" rIns="27432" tIns="18288" bIns="18288" anchor="t">
+            <a:normAutofit/>
           </a:bodyPr>
           <a:lstStyle/>
           <a:p>
@@ -4238,8 +4238,8 @@
         </p:blipFill>
         <p:spPr>
           <a:xfrm>
-            <a:off x="6172200" y="1143000"/>
-            <a:ext cx="5349240" cy="3017520"/>
+            <a:off x="6263640" y="1078992"/>
+            <a:ext cx="5074920" cy="2852928"/>
           </a:xfrm>
           <a:prstGeom prst="rect">
             <a:avLst/>
@@ -4254,8 +4254,8 @@
         </p:nvSpPr>
         <p:spPr>
           <a:xfrm>
-            <a:off x="685800" y="1234440"/>
-            <a:ext cx="2395728" cy="1078992"/>
+            <a:off x="685800" y="1078992"/>
+            <a:ext cx="5074920" cy="941832"/>
           </a:xfrm>
           <a:prstGeom prst="roundRect">
             <a:avLst/>
@@ -4299,8 +4299,8 @@
         </p:nvSpPr>
         <p:spPr>
           <a:xfrm>
-            <a:off x="886968" y="1399032"/>
-            <a:ext cx="1993392" cy="320040"/>
+            <a:off x="905256" y="1225296"/>
+            <a:ext cx="4636008" cy="292608"/>
           </a:xfrm>
           <a:prstGeom prst="rect">
             <a:avLst/>
@@ -4308,13 +4308,13 @@
           <a:noFill/>
         </p:spPr>
         <p:txBody>
-          <a:bodyPr wrap="none" lIns="27432" rIns="27432" tIns="18288" bIns="18288" anchor="t">
-            <a:spAutoFit/>
+          <a:bodyPr wrap="square" lIns="27432" rIns="27432" tIns="18288" bIns="18288" anchor="t">
+            <a:normAutofit/>
           </a:bodyPr>
           <a:lstStyle/>
           <a:p>
             <a:r>
-              <a:rPr sz="1500" b="1">
+              <a:rPr sz="1300" b="1">
                 <a:solidFill>
                   <a:srgbClr val="192634"/>
                 </a:solidFill>
@@ -4333,8 +4333,8 @@
         </p:nvSpPr>
         <p:spPr>
           <a:xfrm>
-            <a:off x="886968" y="1801368"/>
-            <a:ext cx="1993392" cy="393192"/>
+            <a:off x="905256" y="1572768"/>
+            <a:ext cx="4636008" cy="338328"/>
           </a:xfrm>
           <a:prstGeom prst="rect">
             <a:avLst/>
@@ -4342,13 +4342,13 @@
           <a:noFill/>
         </p:spPr>
         <p:txBody>
-          <a:bodyPr wrap="none" lIns="27432" rIns="27432" tIns="18288" bIns="18288" anchor="t">
-            <a:spAutoFit/>
+          <a:bodyPr wrap="square" lIns="27432" rIns="27432" tIns="18288" bIns="18288" anchor="t">
+            <a:normAutofit/>
           </a:bodyPr>
           <a:lstStyle/>
           <a:p>
             <a:r>
-              <a:rPr sz="1100" b="0">
+              <a:rPr sz="900" b="0">
                 <a:solidFill>
                   <a:srgbClr val="495461"/>
                 </a:solidFill>
@@ -4367,8 +4367,8 @@
         </p:nvSpPr>
         <p:spPr>
           <a:xfrm>
-            <a:off x="3383280" y="1234440"/>
-            <a:ext cx="2395728" cy="1078992"/>
+            <a:off x="685800" y="2221991"/>
+            <a:ext cx="5074920" cy="941832"/>
           </a:xfrm>
           <a:prstGeom prst="roundRect">
             <a:avLst/>
@@ -4412,8 +4412,8 @@
         </p:nvSpPr>
         <p:spPr>
           <a:xfrm>
-            <a:off x="3584448" y="1399032"/>
-            <a:ext cx="1993392" cy="320040"/>
+            <a:off x="905256" y="2368295"/>
+            <a:ext cx="4636008" cy="292608"/>
           </a:xfrm>
           <a:prstGeom prst="rect">
             <a:avLst/>
@@ -4421,13 +4421,13 @@
           <a:noFill/>
         </p:spPr>
         <p:txBody>
-          <a:bodyPr wrap="none" lIns="27432" rIns="27432" tIns="18288" bIns="18288" anchor="t">
-            <a:spAutoFit/>
+          <a:bodyPr wrap="square" lIns="27432" rIns="27432" tIns="18288" bIns="18288" anchor="t">
+            <a:normAutofit/>
           </a:bodyPr>
           <a:lstStyle/>
           <a:p>
             <a:r>
-              <a:rPr sz="1500" b="1">
+              <a:rPr sz="1300" b="1">
                 <a:solidFill>
                   <a:srgbClr val="192634"/>
                 </a:solidFill>
@@ -4446,8 +4446,8 @@
         </p:nvSpPr>
         <p:spPr>
           <a:xfrm>
-            <a:off x="3584448" y="1801368"/>
-            <a:ext cx="1993392" cy="393192"/>
+            <a:off x="905256" y="2715767"/>
+            <a:ext cx="4636008" cy="338328"/>
           </a:xfrm>
           <a:prstGeom prst="rect">
             <a:avLst/>
@@ -4455,13 +4455,13 @@
           <a:noFill/>
         </p:spPr>
         <p:txBody>
-          <a:bodyPr wrap="none" lIns="27432" rIns="27432" tIns="18288" bIns="18288" anchor="t">
-            <a:spAutoFit/>
+          <a:bodyPr wrap="square" lIns="27432" rIns="27432" tIns="18288" bIns="18288" anchor="t">
+            <a:normAutofit/>
           </a:bodyPr>
           <a:lstStyle/>
           <a:p>
             <a:r>
-              <a:rPr sz="1100" b="0">
+              <a:rPr sz="900" b="0">
                 <a:solidFill>
                   <a:srgbClr val="495461"/>
                 </a:solidFill>
@@ -4480,8 +4480,8 @@
         </p:nvSpPr>
         <p:spPr>
           <a:xfrm>
-            <a:off x="685800" y="2560320"/>
-            <a:ext cx="2395728" cy="1078992"/>
+            <a:off x="685800" y="3364991"/>
+            <a:ext cx="5074920" cy="941832"/>
           </a:xfrm>
           <a:prstGeom prst="roundRect">
             <a:avLst/>
@@ -4525,8 +4525,8 @@
         </p:nvSpPr>
         <p:spPr>
           <a:xfrm>
-            <a:off x="886968" y="2724912"/>
-            <a:ext cx="1993392" cy="320040"/>
+            <a:off x="905256" y="3511295"/>
+            <a:ext cx="4636008" cy="292608"/>
           </a:xfrm>
           <a:prstGeom prst="rect">
             <a:avLst/>
@@ -4534,13 +4534,13 @@
           <a:noFill/>
         </p:spPr>
         <p:txBody>
-          <a:bodyPr wrap="none" lIns="27432" rIns="27432" tIns="18288" bIns="18288" anchor="t">
-            <a:spAutoFit/>
+          <a:bodyPr wrap="square" lIns="27432" rIns="27432" tIns="18288" bIns="18288" anchor="t">
+            <a:normAutofit/>
           </a:bodyPr>
           <a:lstStyle/>
           <a:p>
             <a:r>
-              <a:rPr sz="1500" b="1">
+              <a:rPr sz="1300" b="1">
                 <a:solidFill>
                   <a:srgbClr val="192634"/>
                 </a:solidFill>
@@ -4559,8 +4559,8 @@
         </p:nvSpPr>
         <p:spPr>
           <a:xfrm>
-            <a:off x="886968" y="3127248"/>
-            <a:ext cx="1993392" cy="393192"/>
+            <a:off x="905256" y="3858767"/>
+            <a:ext cx="4636008" cy="338328"/>
           </a:xfrm>
           <a:prstGeom prst="rect">
             <a:avLst/>
@@ -4568,13 +4568,13 @@
           <a:noFill/>
         </p:spPr>
         <p:txBody>
-          <a:bodyPr wrap="none" lIns="27432" rIns="27432" tIns="18288" bIns="18288" anchor="t">
-            <a:spAutoFit/>
+          <a:bodyPr wrap="square" lIns="27432" rIns="27432" tIns="18288" bIns="18288" anchor="t">
+            <a:normAutofit/>
           </a:bodyPr>
           <a:lstStyle/>
           <a:p>
             <a:r>
-              <a:rPr sz="1100" b="0">
+              <a:rPr sz="900" b="0">
                 <a:solidFill>
                   <a:srgbClr val="495461"/>
                 </a:solidFill>
@@ -4602,8 +4602,8 @@
           <a:noFill/>
         </p:spPr>
         <p:txBody>
-          <a:bodyPr wrap="none" lIns="27432" rIns="27432" tIns="18288" bIns="18288" anchor="t">
-            <a:spAutoFit/>
+          <a:bodyPr wrap="square" lIns="27432" rIns="27432" tIns="18288" bIns="18288" anchor="t">
+            <a:normAutofit/>
           </a:bodyPr>
           <a:lstStyle/>
           <a:p>
@@ -4663,8 +4663,8 @@
           <a:noFill/>
         </p:spPr>
         <p:txBody>
-          <a:bodyPr wrap="none" lIns="27432" rIns="27432" tIns="18288" bIns="18288" anchor="t">
-            <a:spAutoFit/>
+          <a:bodyPr wrap="square" lIns="27432" rIns="27432" tIns="18288" bIns="18288" anchor="t">
+            <a:normAutofit/>
           </a:bodyPr>
           <a:lstStyle/>
           <a:p>
@@ -4697,8 +4697,8 @@
           <a:noFill/>
         </p:spPr>
         <p:txBody>
-          <a:bodyPr wrap="none" lIns="27432" rIns="27432" tIns="18288" bIns="18288" anchor="t">
-            <a:spAutoFit/>
+          <a:bodyPr wrap="square" lIns="27432" rIns="27432" tIns="18288" bIns="18288" anchor="t">
+            <a:normAutofit/>
           </a:bodyPr>
           <a:lstStyle/>
           <a:p>
@@ -4773,8 +4773,8 @@
         </p:blipFill>
         <p:spPr>
           <a:xfrm>
-            <a:off x="6172200" y="1143000"/>
-            <a:ext cx="5349240" cy="3017520"/>
+            <a:off x="6263640" y="1078992"/>
+            <a:ext cx="5074920" cy="2852928"/>
           </a:xfrm>
           <a:prstGeom prst="rect">
             <a:avLst/>
@@ -4789,7 +4789,7 @@
         </p:nvSpPr>
         <p:spPr>
           <a:xfrm>
-            <a:off x="731520" y="1335024"/>
+            <a:off x="731520" y="1243584"/>
             <a:ext cx="100584" cy="100584"/>
           </a:xfrm>
           <a:prstGeom prst="ellipse">
@@ -4832,8 +4832,8 @@
         </p:nvSpPr>
         <p:spPr>
           <a:xfrm>
-            <a:off x="960120" y="1234440"/>
-            <a:ext cx="4754880" cy="530352"/>
+            <a:off x="960120" y="1143000"/>
+            <a:ext cx="4846320" cy="658368"/>
           </a:xfrm>
           <a:prstGeom prst="rect">
             <a:avLst/>
@@ -4841,13 +4841,13 @@
           <a:noFill/>
         </p:spPr>
         <p:txBody>
-          <a:bodyPr wrap="none" lIns="27432" rIns="27432" tIns="18288" bIns="18288" anchor="t">
-            <a:spAutoFit/>
+          <a:bodyPr wrap="square" lIns="27432" rIns="27432" tIns="18288" bIns="18288" anchor="t">
+            <a:normAutofit/>
           </a:bodyPr>
           <a:lstStyle/>
           <a:p>
             <a:r>
-              <a:rPr sz="1400" b="0">
+              <a:rPr sz="1200" b="0">
                 <a:solidFill>
                   <a:srgbClr val="495461"/>
                 </a:solidFill>
@@ -4866,7 +4866,7 @@
         </p:nvSpPr>
         <p:spPr>
           <a:xfrm>
-            <a:off x="731520" y="1956816"/>
+            <a:off x="731520" y="2048256"/>
             <a:ext cx="100584" cy="100584"/>
           </a:xfrm>
           <a:prstGeom prst="ellipse">
@@ -4909,8 +4909,8 @@
         </p:nvSpPr>
         <p:spPr>
           <a:xfrm>
-            <a:off x="960120" y="1856232"/>
-            <a:ext cx="4754880" cy="530352"/>
+            <a:off x="960120" y="1947672"/>
+            <a:ext cx="4846320" cy="658368"/>
           </a:xfrm>
           <a:prstGeom prst="rect">
             <a:avLst/>
@@ -4918,13 +4918,13 @@
           <a:noFill/>
         </p:spPr>
         <p:txBody>
-          <a:bodyPr wrap="none" lIns="27432" rIns="27432" tIns="18288" bIns="18288" anchor="t">
-            <a:spAutoFit/>
+          <a:bodyPr wrap="square" lIns="27432" rIns="27432" tIns="18288" bIns="18288" anchor="t">
+            <a:normAutofit/>
           </a:bodyPr>
           <a:lstStyle/>
           <a:p>
             <a:r>
-              <a:rPr sz="1400" b="0">
+              <a:rPr sz="1200" b="0">
                 <a:solidFill>
                   <a:srgbClr val="495461"/>
                 </a:solidFill>
@@ -4943,7 +4943,7 @@
         </p:nvSpPr>
         <p:spPr>
           <a:xfrm>
-            <a:off x="731520" y="2578608"/>
+            <a:off x="731520" y="2852928"/>
             <a:ext cx="100584" cy="100584"/>
           </a:xfrm>
           <a:prstGeom prst="ellipse">
@@ -4986,8 +4986,8 @@
         </p:nvSpPr>
         <p:spPr>
           <a:xfrm>
-            <a:off x="960120" y="2478024"/>
-            <a:ext cx="4754880" cy="530352"/>
+            <a:off x="960120" y="2752344"/>
+            <a:ext cx="4846320" cy="658368"/>
           </a:xfrm>
           <a:prstGeom prst="rect">
             <a:avLst/>
@@ -4995,13 +4995,13 @@
           <a:noFill/>
         </p:spPr>
         <p:txBody>
-          <a:bodyPr wrap="none" lIns="27432" rIns="27432" tIns="18288" bIns="18288" anchor="t">
-            <a:spAutoFit/>
+          <a:bodyPr wrap="square" lIns="27432" rIns="27432" tIns="18288" bIns="18288" anchor="t">
+            <a:normAutofit/>
           </a:bodyPr>
           <a:lstStyle/>
           <a:p>
             <a:r>
-              <a:rPr sz="1400" b="0">
+              <a:rPr sz="1200" b="0">
                 <a:solidFill>
                   <a:srgbClr val="495461"/>
                 </a:solidFill>
@@ -5020,7 +5020,7 @@
         </p:nvSpPr>
         <p:spPr>
           <a:xfrm>
-            <a:off x="731520" y="3200400"/>
+            <a:off x="731520" y="3657600"/>
             <a:ext cx="100584" cy="100584"/>
           </a:xfrm>
           <a:prstGeom prst="ellipse">
@@ -5063,8 +5063,8 @@
         </p:nvSpPr>
         <p:spPr>
           <a:xfrm>
-            <a:off x="960120" y="3099816"/>
-            <a:ext cx="4754880" cy="530352"/>
+            <a:off x="960120" y="3557016"/>
+            <a:ext cx="4846320" cy="658368"/>
           </a:xfrm>
           <a:prstGeom prst="rect">
             <a:avLst/>
@@ -5072,13 +5072,13 @@
           <a:noFill/>
         </p:spPr>
         <p:txBody>
-          <a:bodyPr wrap="none" lIns="27432" rIns="27432" tIns="18288" bIns="18288" anchor="t">
-            <a:spAutoFit/>
+          <a:bodyPr wrap="square" lIns="27432" rIns="27432" tIns="18288" bIns="18288" anchor="t">
+            <a:normAutofit/>
           </a:bodyPr>
           <a:lstStyle/>
           <a:p>
             <a:r>
-              <a:rPr sz="1400" b="0">
+              <a:rPr sz="1200" b="0">
                 <a:solidFill>
                   <a:srgbClr val="495461"/>
                 </a:solidFill>
@@ -5097,7 +5097,7 @@
         </p:nvSpPr>
         <p:spPr>
           <a:xfrm>
-            <a:off x="731520" y="3822192"/>
+            <a:off x="731520" y="4462272"/>
             <a:ext cx="100584" cy="100584"/>
           </a:xfrm>
           <a:prstGeom prst="ellipse">
@@ -5140,8 +5140,8 @@
         </p:nvSpPr>
         <p:spPr>
           <a:xfrm>
-            <a:off x="960120" y="3721608"/>
-            <a:ext cx="4754880" cy="530352"/>
+            <a:off x="960120" y="4361688"/>
+            <a:ext cx="4846320" cy="658368"/>
           </a:xfrm>
           <a:prstGeom prst="rect">
             <a:avLst/>
@@ -5149,13 +5149,13 @@
           <a:noFill/>
         </p:spPr>
         <p:txBody>
-          <a:bodyPr wrap="none" lIns="27432" rIns="27432" tIns="18288" bIns="18288" anchor="t">
-            <a:spAutoFit/>
+          <a:bodyPr wrap="square" lIns="27432" rIns="27432" tIns="18288" bIns="18288" anchor="t">
+            <a:normAutofit/>
           </a:bodyPr>
           <a:lstStyle/>
           <a:p>
             <a:r>
-              <a:rPr sz="1400" b="0">
+              <a:rPr sz="1200" b="0">
                 <a:solidFill>
                   <a:srgbClr val="495461"/>
                 </a:solidFill>
@@ -5183,8 +5183,8 @@
           <a:noFill/>
         </p:spPr>
         <p:txBody>
-          <a:bodyPr wrap="none" lIns="27432" rIns="27432" tIns="18288" bIns="18288" anchor="t">
-            <a:spAutoFit/>
+          <a:bodyPr wrap="square" lIns="27432" rIns="27432" tIns="18288" bIns="18288" anchor="t">
+            <a:normAutofit/>
           </a:bodyPr>
           <a:lstStyle/>
           <a:p>
@@ -5244,8 +5244,8 @@
           <a:noFill/>
         </p:spPr>
         <p:txBody>
-          <a:bodyPr wrap="none" lIns="27432" rIns="27432" tIns="18288" bIns="18288" anchor="t">
-            <a:spAutoFit/>
+          <a:bodyPr wrap="square" lIns="27432" rIns="27432" tIns="18288" bIns="18288" anchor="t">
+            <a:normAutofit/>
           </a:bodyPr>
           <a:lstStyle/>
           <a:p>
@@ -5278,8 +5278,8 @@
           <a:noFill/>
         </p:spPr>
         <p:txBody>
-          <a:bodyPr wrap="none" lIns="27432" rIns="27432" tIns="18288" bIns="18288" anchor="t">
-            <a:spAutoFit/>
+          <a:bodyPr wrap="square" lIns="27432" rIns="27432" tIns="18288" bIns="18288" anchor="t">
+            <a:normAutofit/>
           </a:bodyPr>
           <a:lstStyle/>
           <a:p>
@@ -5354,8 +5354,8 @@
         </p:blipFill>
         <p:spPr>
           <a:xfrm>
-            <a:off x="6172200" y="1143000"/>
-            <a:ext cx="5349240" cy="3017520"/>
+            <a:off x="6263640" y="1078992"/>
+            <a:ext cx="5074920" cy="2852928"/>
           </a:xfrm>
           <a:prstGeom prst="rect">
             <a:avLst/>
@@ -5370,8 +5370,8 @@
         </p:nvSpPr>
         <p:spPr>
           <a:xfrm>
-            <a:off x="685800" y="1234440"/>
-            <a:ext cx="2395728" cy="1078992"/>
+            <a:off x="685800" y="1078992"/>
+            <a:ext cx="5074920" cy="941832"/>
           </a:xfrm>
           <a:prstGeom prst="roundRect">
             <a:avLst/>
@@ -5415,8 +5415,8 @@
         </p:nvSpPr>
         <p:spPr>
           <a:xfrm>
-            <a:off x="886968" y="1399032"/>
-            <a:ext cx="1993392" cy="320040"/>
+            <a:off x="905256" y="1225296"/>
+            <a:ext cx="4636008" cy="292608"/>
           </a:xfrm>
           <a:prstGeom prst="rect">
             <a:avLst/>
@@ -5424,13 +5424,13 @@
           <a:noFill/>
         </p:spPr>
         <p:txBody>
-          <a:bodyPr wrap="none" lIns="27432" rIns="27432" tIns="18288" bIns="18288" anchor="t">
-            <a:spAutoFit/>
+          <a:bodyPr wrap="square" lIns="27432" rIns="27432" tIns="18288" bIns="18288" anchor="t">
+            <a:normAutofit/>
           </a:bodyPr>
           <a:lstStyle/>
           <a:p>
             <a:r>
-              <a:rPr sz="1500" b="1">
+              <a:rPr sz="1300" b="1">
                 <a:solidFill>
                   <a:srgbClr val="192634"/>
                 </a:solidFill>
@@ -5449,8 +5449,8 @@
         </p:nvSpPr>
         <p:spPr>
           <a:xfrm>
-            <a:off x="886968" y="1801368"/>
-            <a:ext cx="1993392" cy="393192"/>
+            <a:off x="905256" y="1572768"/>
+            <a:ext cx="4636008" cy="338328"/>
           </a:xfrm>
           <a:prstGeom prst="rect">
             <a:avLst/>
@@ -5458,13 +5458,13 @@
           <a:noFill/>
         </p:spPr>
         <p:txBody>
-          <a:bodyPr wrap="none" lIns="27432" rIns="27432" tIns="18288" bIns="18288" anchor="t">
-            <a:spAutoFit/>
+          <a:bodyPr wrap="square" lIns="27432" rIns="27432" tIns="18288" bIns="18288" anchor="t">
+            <a:normAutofit/>
           </a:bodyPr>
           <a:lstStyle/>
           <a:p>
             <a:r>
-              <a:rPr sz="1100" b="0">
+              <a:rPr sz="900" b="0">
                 <a:solidFill>
                   <a:srgbClr val="495461"/>
                 </a:solidFill>
@@ -5483,8 +5483,8 @@
         </p:nvSpPr>
         <p:spPr>
           <a:xfrm>
-            <a:off x="3383280" y="1234440"/>
-            <a:ext cx="2395728" cy="1078992"/>
+            <a:off x="685800" y="2221991"/>
+            <a:ext cx="5074920" cy="941832"/>
           </a:xfrm>
           <a:prstGeom prst="roundRect">
             <a:avLst/>
@@ -5528,8 +5528,8 @@
         </p:nvSpPr>
         <p:spPr>
           <a:xfrm>
-            <a:off x="3584448" y="1399032"/>
-            <a:ext cx="1993392" cy="320040"/>
+            <a:off x="905256" y="2368295"/>
+            <a:ext cx="4636008" cy="292608"/>
           </a:xfrm>
           <a:prstGeom prst="rect">
             <a:avLst/>
@@ -5537,13 +5537,13 @@
           <a:noFill/>
         </p:spPr>
         <p:txBody>
-          <a:bodyPr wrap="none" lIns="27432" rIns="27432" tIns="18288" bIns="18288" anchor="t">
-            <a:spAutoFit/>
+          <a:bodyPr wrap="square" lIns="27432" rIns="27432" tIns="18288" bIns="18288" anchor="t">
+            <a:normAutofit/>
           </a:bodyPr>
           <a:lstStyle/>
           <a:p>
             <a:r>
-              <a:rPr sz="1500" b="1">
+              <a:rPr sz="1300" b="1">
                 <a:solidFill>
                   <a:srgbClr val="192634"/>
                 </a:solidFill>
@@ -5562,8 +5562,8 @@
         </p:nvSpPr>
         <p:spPr>
           <a:xfrm>
-            <a:off x="3584448" y="1801368"/>
-            <a:ext cx="1993392" cy="393192"/>
+            <a:off x="905256" y="2715767"/>
+            <a:ext cx="4636008" cy="338328"/>
           </a:xfrm>
           <a:prstGeom prst="rect">
             <a:avLst/>
@@ -5571,13 +5571,13 @@
           <a:noFill/>
         </p:spPr>
         <p:txBody>
-          <a:bodyPr wrap="none" lIns="27432" rIns="27432" tIns="18288" bIns="18288" anchor="t">
-            <a:spAutoFit/>
+          <a:bodyPr wrap="square" lIns="27432" rIns="27432" tIns="18288" bIns="18288" anchor="t">
+            <a:normAutofit/>
           </a:bodyPr>
           <a:lstStyle/>
           <a:p>
             <a:r>
-              <a:rPr sz="1100" b="0">
+              <a:rPr sz="900" b="0">
                 <a:solidFill>
                   <a:srgbClr val="495461"/>
                 </a:solidFill>
@@ -5596,8 +5596,8 @@
         </p:nvSpPr>
         <p:spPr>
           <a:xfrm>
-            <a:off x="685800" y="2560320"/>
-            <a:ext cx="2395728" cy="1078992"/>
+            <a:off x="685800" y="3364991"/>
+            <a:ext cx="5074920" cy="941832"/>
           </a:xfrm>
           <a:prstGeom prst="roundRect">
             <a:avLst/>
@@ -5641,8 +5641,8 @@
         </p:nvSpPr>
         <p:spPr>
           <a:xfrm>
-            <a:off x="886968" y="2724912"/>
-            <a:ext cx="1993392" cy="320040"/>
+            <a:off x="905256" y="3511295"/>
+            <a:ext cx="4636008" cy="292608"/>
           </a:xfrm>
           <a:prstGeom prst="rect">
             <a:avLst/>
@@ -5650,13 +5650,13 @@
           <a:noFill/>
         </p:spPr>
         <p:txBody>
-          <a:bodyPr wrap="none" lIns="27432" rIns="27432" tIns="18288" bIns="18288" anchor="t">
-            <a:spAutoFit/>
+          <a:bodyPr wrap="square" lIns="27432" rIns="27432" tIns="18288" bIns="18288" anchor="t">
+            <a:normAutofit/>
           </a:bodyPr>
           <a:lstStyle/>
           <a:p>
             <a:r>
-              <a:rPr sz="1500" b="1">
+              <a:rPr sz="1300" b="1">
                 <a:solidFill>
                   <a:srgbClr val="192634"/>
                 </a:solidFill>
@@ -5675,8 +5675,8 @@
         </p:nvSpPr>
         <p:spPr>
           <a:xfrm>
-            <a:off x="886968" y="3127248"/>
-            <a:ext cx="1993392" cy="393192"/>
+            <a:off x="905256" y="3858767"/>
+            <a:ext cx="4636008" cy="338328"/>
           </a:xfrm>
           <a:prstGeom prst="rect">
             <a:avLst/>
@@ -5684,13 +5684,13 @@
           <a:noFill/>
         </p:spPr>
         <p:txBody>
-          <a:bodyPr wrap="none" lIns="27432" rIns="27432" tIns="18288" bIns="18288" anchor="t">
-            <a:spAutoFit/>
+          <a:bodyPr wrap="square" lIns="27432" rIns="27432" tIns="18288" bIns="18288" anchor="t">
+            <a:normAutofit/>
           </a:bodyPr>
           <a:lstStyle/>
           <a:p>
             <a:r>
-              <a:rPr sz="1100" b="0">
+              <a:rPr sz="900" b="0">
                 <a:solidFill>
                   <a:srgbClr val="495461"/>
                 </a:solidFill>
@@ -5709,8 +5709,8 @@
         </p:nvSpPr>
         <p:spPr>
           <a:xfrm>
-            <a:off x="3383280" y="2560320"/>
-            <a:ext cx="2395728" cy="1078992"/>
+            <a:off x="685800" y="4507992"/>
+            <a:ext cx="5074920" cy="941832"/>
           </a:xfrm>
           <a:prstGeom prst="roundRect">
             <a:avLst/>
@@ -5754,8 +5754,8 @@
         </p:nvSpPr>
         <p:spPr>
           <a:xfrm>
-            <a:off x="3584448" y="2724912"/>
-            <a:ext cx="1993392" cy="320040"/>
+            <a:off x="905256" y="4654296"/>
+            <a:ext cx="4636008" cy="292608"/>
           </a:xfrm>
           <a:prstGeom prst="rect">
             <a:avLst/>
@@ -5763,13 +5763,13 @@
           <a:noFill/>
         </p:spPr>
         <p:txBody>
-          <a:bodyPr wrap="none" lIns="27432" rIns="27432" tIns="18288" bIns="18288" anchor="t">
-            <a:spAutoFit/>
+          <a:bodyPr wrap="square" lIns="27432" rIns="27432" tIns="18288" bIns="18288" anchor="t">
+            <a:normAutofit/>
           </a:bodyPr>
           <a:lstStyle/>
           <a:p>
             <a:r>
-              <a:rPr sz="1500" b="1">
+              <a:rPr sz="1300" b="1">
                 <a:solidFill>
                   <a:srgbClr val="192634"/>
                 </a:solidFill>
@@ -5788,8 +5788,8 @@
         </p:nvSpPr>
         <p:spPr>
           <a:xfrm>
-            <a:off x="3584448" y="3127248"/>
-            <a:ext cx="1993392" cy="393192"/>
+            <a:off x="905256" y="5001768"/>
+            <a:ext cx="4636008" cy="338328"/>
           </a:xfrm>
           <a:prstGeom prst="rect">
             <a:avLst/>
@@ -5797,13 +5797,13 @@
           <a:noFill/>
         </p:spPr>
         <p:txBody>
-          <a:bodyPr wrap="none" lIns="27432" rIns="27432" tIns="18288" bIns="18288" anchor="t">
-            <a:spAutoFit/>
+          <a:bodyPr wrap="square" lIns="27432" rIns="27432" tIns="18288" bIns="18288" anchor="t">
+            <a:normAutofit/>
           </a:bodyPr>
           <a:lstStyle/>
           <a:p>
             <a:r>
-              <a:rPr sz="1100" b="0">
+              <a:rPr sz="900" b="0">
                 <a:solidFill>
                   <a:srgbClr val="495461"/>
                 </a:solidFill>
@@ -5831,8 +5831,8 @@
           <a:noFill/>
         </p:spPr>
         <p:txBody>
-          <a:bodyPr wrap="none" lIns="27432" rIns="27432" tIns="18288" bIns="18288" anchor="t">
-            <a:spAutoFit/>
+          <a:bodyPr wrap="square" lIns="27432" rIns="27432" tIns="18288" bIns="18288" anchor="t">
+            <a:normAutofit/>
           </a:bodyPr>
           <a:lstStyle/>
           <a:p>
@@ -5892,8 +5892,8 @@
           <a:noFill/>
         </p:spPr>
         <p:txBody>
-          <a:bodyPr wrap="none" lIns="27432" rIns="27432" tIns="18288" bIns="18288" anchor="t">
-            <a:spAutoFit/>
+          <a:bodyPr wrap="square" lIns="27432" rIns="27432" tIns="18288" bIns="18288" anchor="t">
+            <a:normAutofit/>
           </a:bodyPr>
           <a:lstStyle/>
           <a:p>
@@ -5926,8 +5926,8 @@
           <a:noFill/>
         </p:spPr>
         <p:txBody>
-          <a:bodyPr wrap="none" lIns="27432" rIns="27432" tIns="18288" bIns="18288" anchor="t">
-            <a:spAutoFit/>
+          <a:bodyPr wrap="square" lIns="27432" rIns="27432" tIns="18288" bIns="18288" anchor="t">
+            <a:normAutofit/>
           </a:bodyPr>
           <a:lstStyle/>
           <a:p>
@@ -6002,8 +6002,8 @@
         </p:blipFill>
         <p:spPr>
           <a:xfrm>
-            <a:off x="6172200" y="1143000"/>
-            <a:ext cx="5349240" cy="3017520"/>
+            <a:off x="6263640" y="1078992"/>
+            <a:ext cx="5074920" cy="2852928"/>
           </a:xfrm>
           <a:prstGeom prst="rect">
             <a:avLst/>
@@ -6018,7 +6018,7 @@
         </p:nvSpPr>
         <p:spPr>
           <a:xfrm>
-            <a:off x="731520" y="1335024"/>
+            <a:off x="731520" y="1243584"/>
             <a:ext cx="100584" cy="100584"/>
           </a:xfrm>
           <a:prstGeom prst="ellipse">
@@ -6061,8 +6061,8 @@
         </p:nvSpPr>
         <p:spPr>
           <a:xfrm>
-            <a:off x="960120" y="1234440"/>
-            <a:ext cx="4754880" cy="530352"/>
+            <a:off x="960120" y="1143000"/>
+            <a:ext cx="4846320" cy="658368"/>
           </a:xfrm>
           <a:prstGeom prst="rect">
             <a:avLst/>
@@ -6070,13 +6070,13 @@
           <a:noFill/>
         </p:spPr>
         <p:txBody>
-          <a:bodyPr wrap="none" lIns="27432" rIns="27432" tIns="18288" bIns="18288" anchor="t">
-            <a:spAutoFit/>
+          <a:bodyPr wrap="square" lIns="27432" rIns="27432" tIns="18288" bIns="18288" anchor="t">
+            <a:normAutofit/>
           </a:bodyPr>
           <a:lstStyle/>
           <a:p>
             <a:r>
-              <a:rPr sz="1400" b="0">
+              <a:rPr sz="1200" b="0">
                 <a:solidFill>
                   <a:srgbClr val="495461"/>
                 </a:solidFill>
@@ -6095,7 +6095,7 @@
         </p:nvSpPr>
         <p:spPr>
           <a:xfrm>
-            <a:off x="731520" y="1956816"/>
+            <a:off x="731520" y="2048256"/>
             <a:ext cx="100584" cy="100584"/>
           </a:xfrm>
           <a:prstGeom prst="ellipse">
@@ -6138,8 +6138,8 @@
         </p:nvSpPr>
         <p:spPr>
           <a:xfrm>
-            <a:off x="960120" y="1856232"/>
-            <a:ext cx="4754880" cy="530352"/>
+            <a:off x="960120" y="1947672"/>
+            <a:ext cx="4846320" cy="658368"/>
           </a:xfrm>
           <a:prstGeom prst="rect">
             <a:avLst/>
@@ -6147,13 +6147,13 @@
           <a:noFill/>
         </p:spPr>
         <p:txBody>
-          <a:bodyPr wrap="none" lIns="27432" rIns="27432" tIns="18288" bIns="18288" anchor="t">
-            <a:spAutoFit/>
+          <a:bodyPr wrap="square" lIns="27432" rIns="27432" tIns="18288" bIns="18288" anchor="t">
+            <a:normAutofit/>
           </a:bodyPr>
           <a:lstStyle/>
           <a:p>
             <a:r>
-              <a:rPr sz="1400" b="0">
+              <a:rPr sz="1200" b="0">
                 <a:solidFill>
                   <a:srgbClr val="495461"/>
                 </a:solidFill>
@@ -6172,7 +6172,7 @@
         </p:nvSpPr>
         <p:spPr>
           <a:xfrm>
-            <a:off x="731520" y="2578608"/>
+            <a:off x="731520" y="2852928"/>
             <a:ext cx="100584" cy="100584"/>
           </a:xfrm>
           <a:prstGeom prst="ellipse">
@@ -6215,8 +6215,8 @@
         </p:nvSpPr>
         <p:spPr>
           <a:xfrm>
-            <a:off x="960120" y="2478024"/>
-            <a:ext cx="4754880" cy="530352"/>
+            <a:off x="960120" y="2752344"/>
+            <a:ext cx="4846320" cy="658368"/>
           </a:xfrm>
           <a:prstGeom prst="rect">
             <a:avLst/>
@@ -6224,13 +6224,13 @@
           <a:noFill/>
         </p:spPr>
         <p:txBody>
-          <a:bodyPr wrap="none" lIns="27432" rIns="27432" tIns="18288" bIns="18288" anchor="t">
-            <a:spAutoFit/>
+          <a:bodyPr wrap="square" lIns="27432" rIns="27432" tIns="18288" bIns="18288" anchor="t">
+            <a:normAutofit/>
           </a:bodyPr>
           <a:lstStyle/>
           <a:p>
             <a:r>
-              <a:rPr sz="1400" b="0">
+              <a:rPr sz="1200" b="0">
                 <a:solidFill>
                   <a:srgbClr val="495461"/>
                 </a:solidFill>
@@ -6249,7 +6249,7 @@
         </p:nvSpPr>
         <p:spPr>
           <a:xfrm>
-            <a:off x="731520" y="3200400"/>
+            <a:off x="731520" y="3657600"/>
             <a:ext cx="100584" cy="100584"/>
           </a:xfrm>
           <a:prstGeom prst="ellipse">
@@ -6292,8 +6292,8 @@
         </p:nvSpPr>
         <p:spPr>
           <a:xfrm>
-            <a:off x="960120" y="3099816"/>
-            <a:ext cx="4754880" cy="530352"/>
+            <a:off x="960120" y="3557016"/>
+            <a:ext cx="4846320" cy="658368"/>
           </a:xfrm>
           <a:prstGeom prst="rect">
             <a:avLst/>
@@ -6301,13 +6301,13 @@
           <a:noFill/>
         </p:spPr>
         <p:txBody>
-          <a:bodyPr wrap="none" lIns="27432" rIns="27432" tIns="18288" bIns="18288" anchor="t">
-            <a:spAutoFit/>
+          <a:bodyPr wrap="square" lIns="27432" rIns="27432" tIns="18288" bIns="18288" anchor="t">
+            <a:normAutofit/>
           </a:bodyPr>
           <a:lstStyle/>
           <a:p>
             <a:r>
-              <a:rPr sz="1400" b="0">
+              <a:rPr sz="1200" b="0">
                 <a:solidFill>
                   <a:srgbClr val="495461"/>
                 </a:solidFill>
@@ -6335,8 +6335,8 @@
           <a:noFill/>
         </p:spPr>
         <p:txBody>
-          <a:bodyPr wrap="none" lIns="27432" rIns="27432" tIns="18288" bIns="18288" anchor="t">
-            <a:spAutoFit/>
+          <a:bodyPr wrap="square" lIns="27432" rIns="27432" tIns="18288" bIns="18288" anchor="t">
+            <a:normAutofit/>
           </a:bodyPr>
           <a:lstStyle/>
           <a:p>
@@ -6396,8 +6396,8 @@
           <a:noFill/>
         </p:spPr>
         <p:txBody>
-          <a:bodyPr wrap="none" lIns="27432" rIns="27432" tIns="18288" bIns="18288" anchor="t">
-            <a:spAutoFit/>
+          <a:bodyPr wrap="square" lIns="27432" rIns="27432" tIns="18288" bIns="18288" anchor="t">
+            <a:normAutofit/>
           </a:bodyPr>
           <a:lstStyle/>
           <a:p>
@@ -6430,8 +6430,8 @@
           <a:noFill/>
         </p:spPr>
         <p:txBody>
-          <a:bodyPr wrap="none" lIns="27432" rIns="27432" tIns="18288" bIns="18288" anchor="t">
-            <a:spAutoFit/>
+          <a:bodyPr wrap="square" lIns="27432" rIns="27432" tIns="18288" bIns="18288" anchor="t">
+            <a:normAutofit/>
           </a:bodyPr>
           <a:lstStyle/>
           <a:p>
@@ -6506,8 +6506,8 @@
         </p:blipFill>
         <p:spPr>
           <a:xfrm>
-            <a:off x="6172200" y="1143000"/>
-            <a:ext cx="5349240" cy="3017520"/>
+            <a:off x="6263640" y="1078992"/>
+            <a:ext cx="5074920" cy="2852928"/>
           </a:xfrm>
           <a:prstGeom prst="rect">
             <a:avLst/>
@@ -6522,8 +6522,8 @@
         </p:nvSpPr>
         <p:spPr>
           <a:xfrm>
-            <a:off x="685800" y="1234440"/>
-            <a:ext cx="2395728" cy="1078992"/>
+            <a:off x="685800" y="1078992"/>
+            <a:ext cx="5074920" cy="941832"/>
           </a:xfrm>
           <a:prstGeom prst="roundRect">
             <a:avLst/>
@@ -6567,8 +6567,8 @@
         </p:nvSpPr>
         <p:spPr>
           <a:xfrm>
-            <a:off x="886968" y="1399032"/>
-            <a:ext cx="1993392" cy="320040"/>
+            <a:off x="905256" y="1225296"/>
+            <a:ext cx="4636008" cy="292608"/>
           </a:xfrm>
           <a:prstGeom prst="rect">
             <a:avLst/>
@@ -6576,13 +6576,13 @@
           <a:noFill/>
         </p:spPr>
         <p:txBody>
-          <a:bodyPr wrap="none" lIns="27432" rIns="27432" tIns="18288" bIns="18288" anchor="t">
-            <a:spAutoFit/>
+          <a:bodyPr wrap="square" lIns="27432" rIns="27432" tIns="18288" bIns="18288" anchor="t">
+            <a:normAutofit/>
           </a:bodyPr>
           <a:lstStyle/>
           <a:p>
             <a:r>
-              <a:rPr sz="1500" b="1">
+              <a:rPr sz="1300" b="1">
                 <a:solidFill>
                   <a:srgbClr val="192634"/>
                 </a:solidFill>
@@ -6601,8 +6601,8 @@
         </p:nvSpPr>
         <p:spPr>
           <a:xfrm>
-            <a:off x="886968" y="1801368"/>
-            <a:ext cx="1993392" cy="393192"/>
+            <a:off x="905256" y="1572768"/>
+            <a:ext cx="4636008" cy="338328"/>
           </a:xfrm>
           <a:prstGeom prst="rect">
             <a:avLst/>
@@ -6610,13 +6610,13 @@
           <a:noFill/>
         </p:spPr>
         <p:txBody>
-          <a:bodyPr wrap="none" lIns="27432" rIns="27432" tIns="18288" bIns="18288" anchor="t">
-            <a:spAutoFit/>
+          <a:bodyPr wrap="square" lIns="27432" rIns="27432" tIns="18288" bIns="18288" anchor="t">
+            <a:normAutofit/>
           </a:bodyPr>
           <a:lstStyle/>
           <a:p>
             <a:r>
-              <a:rPr sz="1100" b="0">
+              <a:rPr sz="900" b="0">
                 <a:solidFill>
                   <a:srgbClr val="495461"/>
                 </a:solidFill>
@@ -6635,8 +6635,8 @@
         </p:nvSpPr>
         <p:spPr>
           <a:xfrm>
-            <a:off x="3383280" y="1234440"/>
-            <a:ext cx="2395728" cy="1078992"/>
+            <a:off x="685800" y="2221991"/>
+            <a:ext cx="5074920" cy="941832"/>
           </a:xfrm>
           <a:prstGeom prst="roundRect">
             <a:avLst/>
@@ -6680,8 +6680,8 @@
         </p:nvSpPr>
         <p:spPr>
           <a:xfrm>
-            <a:off x="3584448" y="1399032"/>
-            <a:ext cx="1993392" cy="320040"/>
+            <a:off x="905256" y="2368295"/>
+            <a:ext cx="4636008" cy="292608"/>
           </a:xfrm>
           <a:prstGeom prst="rect">
             <a:avLst/>
@@ -6689,13 +6689,13 @@
           <a:noFill/>
         </p:spPr>
         <p:txBody>
-          <a:bodyPr wrap="none" lIns="27432" rIns="27432" tIns="18288" bIns="18288" anchor="t">
-            <a:spAutoFit/>
+          <a:bodyPr wrap="square" lIns="27432" rIns="27432" tIns="18288" bIns="18288" anchor="t">
+            <a:normAutofit/>
           </a:bodyPr>
           <a:lstStyle/>
           <a:p>
             <a:r>
-              <a:rPr sz="1500" b="1">
+              <a:rPr sz="1300" b="1">
                 <a:solidFill>
                   <a:srgbClr val="192634"/>
                 </a:solidFill>
@@ -6714,8 +6714,8 @@
         </p:nvSpPr>
         <p:spPr>
           <a:xfrm>
-            <a:off x="3584448" y="1801368"/>
-            <a:ext cx="1993392" cy="393192"/>
+            <a:off x="905256" y="2715767"/>
+            <a:ext cx="4636008" cy="338328"/>
           </a:xfrm>
           <a:prstGeom prst="rect">
             <a:avLst/>
@@ -6723,13 +6723,13 @@
           <a:noFill/>
         </p:spPr>
         <p:txBody>
-          <a:bodyPr wrap="none" lIns="27432" rIns="27432" tIns="18288" bIns="18288" anchor="t">
-            <a:spAutoFit/>
+          <a:bodyPr wrap="square" lIns="27432" rIns="27432" tIns="18288" bIns="18288" anchor="t">
+            <a:normAutofit/>
           </a:bodyPr>
           <a:lstStyle/>
           <a:p>
             <a:r>
-              <a:rPr sz="1100" b="0">
+              <a:rPr sz="900" b="0">
                 <a:solidFill>
                   <a:srgbClr val="495461"/>
                 </a:solidFill>
@@ -6748,8 +6748,8 @@
         </p:nvSpPr>
         <p:spPr>
           <a:xfrm>
-            <a:off x="685800" y="2560320"/>
-            <a:ext cx="2395728" cy="1078992"/>
+            <a:off x="685800" y="3364991"/>
+            <a:ext cx="5074920" cy="941832"/>
           </a:xfrm>
           <a:prstGeom prst="roundRect">
             <a:avLst/>
@@ -6793,8 +6793,8 @@
         </p:nvSpPr>
         <p:spPr>
           <a:xfrm>
-            <a:off x="886968" y="2724912"/>
-            <a:ext cx="1993392" cy="320040"/>
+            <a:off x="905256" y="3511295"/>
+            <a:ext cx="4636008" cy="292608"/>
           </a:xfrm>
           <a:prstGeom prst="rect">
             <a:avLst/>
@@ -6802,13 +6802,13 @@
           <a:noFill/>
         </p:spPr>
         <p:txBody>
-          <a:bodyPr wrap="none" lIns="27432" rIns="27432" tIns="18288" bIns="18288" anchor="t">
-            <a:spAutoFit/>
+          <a:bodyPr wrap="square" lIns="27432" rIns="27432" tIns="18288" bIns="18288" anchor="t">
+            <a:normAutofit/>
           </a:bodyPr>
           <a:lstStyle/>
           <a:p>
             <a:r>
-              <a:rPr sz="1500" b="1">
+              <a:rPr sz="1300" b="1">
                 <a:solidFill>
                   <a:srgbClr val="192634"/>
                 </a:solidFill>
@@ -6827,8 +6827,8 @@
         </p:nvSpPr>
         <p:spPr>
           <a:xfrm>
-            <a:off x="886968" y="3127248"/>
-            <a:ext cx="1993392" cy="393192"/>
+            <a:off x="905256" y="3858767"/>
+            <a:ext cx="4636008" cy="338328"/>
           </a:xfrm>
           <a:prstGeom prst="rect">
             <a:avLst/>
@@ -6836,13 +6836,13 @@
           <a:noFill/>
         </p:spPr>
         <p:txBody>
-          <a:bodyPr wrap="none" lIns="27432" rIns="27432" tIns="18288" bIns="18288" anchor="t">
-            <a:spAutoFit/>
+          <a:bodyPr wrap="square" lIns="27432" rIns="27432" tIns="18288" bIns="18288" anchor="t">
+            <a:normAutofit/>
           </a:bodyPr>
           <a:lstStyle/>
           <a:p>
             <a:r>
-              <a:rPr sz="1100" b="0">
+              <a:rPr sz="900" b="0">
                 <a:solidFill>
                   <a:srgbClr val="495461"/>
                 </a:solidFill>
@@ -6861,8 +6861,8 @@
         </p:nvSpPr>
         <p:spPr>
           <a:xfrm>
-            <a:off x="3383280" y="2560320"/>
-            <a:ext cx="2395728" cy="1078992"/>
+            <a:off x="685800" y="4507992"/>
+            <a:ext cx="5074920" cy="941832"/>
           </a:xfrm>
           <a:prstGeom prst="roundRect">
             <a:avLst/>
@@ -6906,8 +6906,8 @@
         </p:nvSpPr>
         <p:spPr>
           <a:xfrm>
-            <a:off x="3584448" y="2724912"/>
-            <a:ext cx="1993392" cy="320040"/>
+            <a:off x="905256" y="4654296"/>
+            <a:ext cx="4636008" cy="292608"/>
           </a:xfrm>
           <a:prstGeom prst="rect">
             <a:avLst/>
@@ -6915,13 +6915,13 @@
           <a:noFill/>
         </p:spPr>
         <p:txBody>
-          <a:bodyPr wrap="none" lIns="27432" rIns="27432" tIns="18288" bIns="18288" anchor="t">
-            <a:spAutoFit/>
+          <a:bodyPr wrap="square" lIns="27432" rIns="27432" tIns="18288" bIns="18288" anchor="t">
+            <a:normAutofit/>
           </a:bodyPr>
           <a:lstStyle/>
           <a:p>
             <a:r>
-              <a:rPr sz="1500" b="1">
+              <a:rPr sz="1300" b="1">
                 <a:solidFill>
                   <a:srgbClr val="192634"/>
                 </a:solidFill>
@@ -6940,8 +6940,8 @@
         </p:nvSpPr>
         <p:spPr>
           <a:xfrm>
-            <a:off x="3584448" y="3127248"/>
-            <a:ext cx="1993392" cy="393192"/>
+            <a:off x="905256" y="5001768"/>
+            <a:ext cx="4636008" cy="338328"/>
           </a:xfrm>
           <a:prstGeom prst="rect">
             <a:avLst/>
@@ -6949,13 +6949,13 @@
           <a:noFill/>
         </p:spPr>
         <p:txBody>
-          <a:bodyPr wrap="none" lIns="27432" rIns="27432" tIns="18288" bIns="18288" anchor="t">
-            <a:spAutoFit/>
+          <a:bodyPr wrap="square" lIns="27432" rIns="27432" tIns="18288" bIns="18288" anchor="t">
+            <a:normAutofit/>
           </a:bodyPr>
           <a:lstStyle/>
           <a:p>
             <a:r>
-              <a:rPr sz="1100" b="0">
+              <a:rPr sz="900" b="0">
                 <a:solidFill>
                   <a:srgbClr val="495461"/>
                 </a:solidFill>
@@ -6983,8 +6983,8 @@
           <a:noFill/>
         </p:spPr>
         <p:txBody>
-          <a:bodyPr wrap="none" lIns="27432" rIns="27432" tIns="18288" bIns="18288" anchor="t">
-            <a:spAutoFit/>
+          <a:bodyPr wrap="square" lIns="27432" rIns="27432" tIns="18288" bIns="18288" anchor="t">
+            <a:normAutofit/>
           </a:bodyPr>
           <a:lstStyle/>
           <a:p>
@@ -7044,8 +7044,8 @@
           <a:noFill/>
         </p:spPr>
         <p:txBody>
-          <a:bodyPr wrap="none" lIns="27432" rIns="27432" tIns="18288" bIns="18288" anchor="t">
-            <a:spAutoFit/>
+          <a:bodyPr wrap="square" lIns="27432" rIns="27432" tIns="18288" bIns="18288" anchor="t">
+            <a:normAutofit/>
           </a:bodyPr>
           <a:lstStyle/>
           <a:p>
@@ -7078,8 +7078,8 @@
           <a:noFill/>
         </p:spPr>
         <p:txBody>
-          <a:bodyPr wrap="none" lIns="27432" rIns="27432" tIns="18288" bIns="18288" anchor="t">
-            <a:spAutoFit/>
+          <a:bodyPr wrap="square" lIns="27432" rIns="27432" tIns="18288" bIns="18288" anchor="t">
+            <a:normAutofit/>
           </a:bodyPr>
           <a:lstStyle/>
           <a:p>
@@ -7154,8 +7154,8 @@
         </p:blipFill>
         <p:spPr>
           <a:xfrm>
-            <a:off x="6172200" y="1143000"/>
-            <a:ext cx="5349240" cy="3017520"/>
+            <a:off x="6263640" y="1078992"/>
+            <a:ext cx="5074920" cy="2852928"/>
           </a:xfrm>
           <a:prstGeom prst="rect">
             <a:avLst/>
@@ -7170,8 +7170,8 @@
         </p:nvSpPr>
         <p:spPr>
           <a:xfrm>
-            <a:off x="685800" y="1234440"/>
-            <a:ext cx="2395728" cy="1078992"/>
+            <a:off x="685800" y="1078992"/>
+            <a:ext cx="5074920" cy="941832"/>
           </a:xfrm>
           <a:prstGeom prst="roundRect">
             <a:avLst/>
@@ -7215,8 +7215,8 @@
         </p:nvSpPr>
         <p:spPr>
           <a:xfrm>
-            <a:off x="886968" y="1399032"/>
-            <a:ext cx="1993392" cy="320040"/>
+            <a:off x="905256" y="1225296"/>
+            <a:ext cx="4636008" cy="292608"/>
           </a:xfrm>
           <a:prstGeom prst="rect">
             <a:avLst/>
@@ -7224,13 +7224,13 @@
           <a:noFill/>
         </p:spPr>
         <p:txBody>
-          <a:bodyPr wrap="none" lIns="27432" rIns="27432" tIns="18288" bIns="18288" anchor="t">
-            <a:spAutoFit/>
+          <a:bodyPr wrap="square" lIns="27432" rIns="27432" tIns="18288" bIns="18288" anchor="t">
+            <a:normAutofit/>
           </a:bodyPr>
           <a:lstStyle/>
           <a:p>
             <a:r>
-              <a:rPr sz="1500" b="1">
+              <a:rPr sz="1300" b="1">
                 <a:solidFill>
                   <a:srgbClr val="192634"/>
                 </a:solidFill>
@@ -7249,8 +7249,8 @@
         </p:nvSpPr>
         <p:spPr>
           <a:xfrm>
-            <a:off x="886968" y="1801368"/>
-            <a:ext cx="1993392" cy="393192"/>
+            <a:off x="905256" y="1572768"/>
+            <a:ext cx="4636008" cy="338328"/>
           </a:xfrm>
           <a:prstGeom prst="rect">
             <a:avLst/>
@@ -7258,13 +7258,13 @@
           <a:noFill/>
         </p:spPr>
         <p:txBody>
-          <a:bodyPr wrap="none" lIns="27432" rIns="27432" tIns="18288" bIns="18288" anchor="t">
-            <a:spAutoFit/>
+          <a:bodyPr wrap="square" lIns="27432" rIns="27432" tIns="18288" bIns="18288" anchor="t">
+            <a:normAutofit/>
           </a:bodyPr>
           <a:lstStyle/>
           <a:p>
             <a:r>
-              <a:rPr sz="1100" b="0">
+              <a:rPr sz="900" b="0">
                 <a:solidFill>
                   <a:srgbClr val="495461"/>
                 </a:solidFill>
@@ -7283,8 +7283,8 @@
         </p:nvSpPr>
         <p:spPr>
           <a:xfrm>
-            <a:off x="3383280" y="1234440"/>
-            <a:ext cx="2395728" cy="1078992"/>
+            <a:off x="685800" y="2221991"/>
+            <a:ext cx="5074920" cy="941832"/>
           </a:xfrm>
           <a:prstGeom prst="roundRect">
             <a:avLst/>
@@ -7328,8 +7328,8 @@
         </p:nvSpPr>
         <p:spPr>
           <a:xfrm>
-            <a:off x="3584448" y="1399032"/>
-            <a:ext cx="1993392" cy="320040"/>
+            <a:off x="905256" y="2368295"/>
+            <a:ext cx="4636008" cy="292608"/>
           </a:xfrm>
           <a:prstGeom prst="rect">
             <a:avLst/>
@@ -7337,13 +7337,13 @@
           <a:noFill/>
         </p:spPr>
         <p:txBody>
-          <a:bodyPr wrap="none" lIns="27432" rIns="27432" tIns="18288" bIns="18288" anchor="t">
-            <a:spAutoFit/>
+          <a:bodyPr wrap="square" lIns="27432" rIns="27432" tIns="18288" bIns="18288" anchor="t">
+            <a:normAutofit/>
           </a:bodyPr>
           <a:lstStyle/>
           <a:p>
             <a:r>
-              <a:rPr sz="1500" b="1">
+              <a:rPr sz="1300" b="1">
                 <a:solidFill>
                   <a:srgbClr val="192634"/>
                 </a:solidFill>
@@ -7362,8 +7362,8 @@
         </p:nvSpPr>
         <p:spPr>
           <a:xfrm>
-            <a:off x="3584448" y="1801368"/>
-            <a:ext cx="1993392" cy="393192"/>
+            <a:off x="905256" y="2715767"/>
+            <a:ext cx="4636008" cy="338328"/>
           </a:xfrm>
           <a:prstGeom prst="rect">
             <a:avLst/>
@@ -7371,13 +7371,13 @@
           <a:noFill/>
         </p:spPr>
         <p:txBody>
-          <a:bodyPr wrap="none" lIns="27432" rIns="27432" tIns="18288" bIns="18288" anchor="t">
-            <a:spAutoFit/>
+          <a:bodyPr wrap="square" lIns="27432" rIns="27432" tIns="18288" bIns="18288" anchor="t">
+            <a:normAutofit/>
           </a:bodyPr>
           <a:lstStyle/>
           <a:p>
             <a:r>
-              <a:rPr sz="1100" b="0">
+              <a:rPr sz="900" b="0">
                 <a:solidFill>
                   <a:srgbClr val="495461"/>
                 </a:solidFill>
@@ -7396,8 +7396,8 @@
         </p:nvSpPr>
         <p:spPr>
           <a:xfrm>
-            <a:off x="685800" y="2560320"/>
-            <a:ext cx="2395728" cy="1078992"/>
+            <a:off x="685800" y="3364991"/>
+            <a:ext cx="5074920" cy="941832"/>
           </a:xfrm>
           <a:prstGeom prst="roundRect">
             <a:avLst/>
@@ -7441,8 +7441,8 @@
         </p:nvSpPr>
         <p:spPr>
           <a:xfrm>
-            <a:off x="886968" y="2724912"/>
-            <a:ext cx="1993392" cy="320040"/>
+            <a:off x="905256" y="3511295"/>
+            <a:ext cx="4636008" cy="292608"/>
           </a:xfrm>
           <a:prstGeom prst="rect">
             <a:avLst/>
@@ -7450,13 +7450,13 @@
           <a:noFill/>
         </p:spPr>
         <p:txBody>
-          <a:bodyPr wrap="none" lIns="27432" rIns="27432" tIns="18288" bIns="18288" anchor="t">
-            <a:spAutoFit/>
+          <a:bodyPr wrap="square" lIns="27432" rIns="27432" tIns="18288" bIns="18288" anchor="t">
+            <a:normAutofit/>
           </a:bodyPr>
           <a:lstStyle/>
           <a:p>
             <a:r>
-              <a:rPr sz="1500" b="1">
+              <a:rPr sz="1300" b="1">
                 <a:solidFill>
                   <a:srgbClr val="192634"/>
                 </a:solidFill>
@@ -7475,8 +7475,8 @@
         </p:nvSpPr>
         <p:spPr>
           <a:xfrm>
-            <a:off x="886968" y="3127248"/>
-            <a:ext cx="1993392" cy="393192"/>
+            <a:off x="905256" y="3858767"/>
+            <a:ext cx="4636008" cy="338328"/>
           </a:xfrm>
           <a:prstGeom prst="rect">
             <a:avLst/>
@@ -7484,13 +7484,13 @@
           <a:noFill/>
         </p:spPr>
         <p:txBody>
-          <a:bodyPr wrap="none" lIns="27432" rIns="27432" tIns="18288" bIns="18288" anchor="t">
-            <a:spAutoFit/>
+          <a:bodyPr wrap="square" lIns="27432" rIns="27432" tIns="18288" bIns="18288" anchor="t">
+            <a:normAutofit/>
           </a:bodyPr>
           <a:lstStyle/>
           <a:p>
             <a:r>
-              <a:rPr sz="1100" b="0">
+              <a:rPr sz="900" b="0">
                 <a:solidFill>
                   <a:srgbClr val="495461"/>
                 </a:solidFill>
@@ -7518,8 +7518,8 @@
           <a:noFill/>
         </p:spPr>
         <p:txBody>
-          <a:bodyPr wrap="none" lIns="27432" rIns="27432" tIns="18288" bIns="18288" anchor="t">
-            <a:spAutoFit/>
+          <a:bodyPr wrap="square" lIns="27432" rIns="27432" tIns="18288" bIns="18288" anchor="t">
+            <a:normAutofit/>
           </a:bodyPr>
           <a:lstStyle/>
           <a:p>
@@ -7579,8 +7579,8 @@
           <a:noFill/>
         </p:spPr>
         <p:txBody>
-          <a:bodyPr wrap="none" lIns="27432" rIns="27432" tIns="18288" bIns="18288" anchor="t">
-            <a:spAutoFit/>
+          <a:bodyPr wrap="square" lIns="27432" rIns="27432" tIns="18288" bIns="18288" anchor="t">
+            <a:normAutofit/>
           </a:bodyPr>
           <a:lstStyle/>
           <a:p>
@@ -7613,8 +7613,8 @@
           <a:noFill/>
         </p:spPr>
         <p:txBody>
-          <a:bodyPr wrap="none" lIns="27432" rIns="27432" tIns="18288" bIns="18288" anchor="t">
-            <a:spAutoFit/>
+          <a:bodyPr wrap="square" lIns="27432" rIns="27432" tIns="18288" bIns="18288" anchor="t">
+            <a:normAutofit/>
           </a:bodyPr>
           <a:lstStyle/>
           <a:p>
@@ -7689,8 +7689,8 @@
         </p:blipFill>
         <p:spPr>
           <a:xfrm>
-            <a:off x="6172200" y="1143000"/>
-            <a:ext cx="5349240" cy="3017520"/>
+            <a:off x="6263640" y="1078992"/>
+            <a:ext cx="5074920" cy="2852928"/>
           </a:xfrm>
           <a:prstGeom prst="rect">
             <a:avLst/>
@@ -7705,7 +7705,7 @@
         </p:nvSpPr>
         <p:spPr>
           <a:xfrm>
-            <a:off x="731520" y="1335024"/>
+            <a:off x="731520" y="1243584"/>
             <a:ext cx="100584" cy="100584"/>
           </a:xfrm>
           <a:prstGeom prst="ellipse">
@@ -7748,8 +7748,8 @@
         </p:nvSpPr>
         <p:spPr>
           <a:xfrm>
-            <a:off x="960120" y="1234440"/>
-            <a:ext cx="4754880" cy="530352"/>
+            <a:off x="960120" y="1143000"/>
+            <a:ext cx="4846320" cy="658368"/>
           </a:xfrm>
           <a:prstGeom prst="rect">
             <a:avLst/>
@@ -7757,13 +7757,13 @@
           <a:noFill/>
         </p:spPr>
         <p:txBody>
-          <a:bodyPr wrap="none" lIns="27432" rIns="27432" tIns="18288" bIns="18288" anchor="t">
-            <a:spAutoFit/>
+          <a:bodyPr wrap="square" lIns="27432" rIns="27432" tIns="18288" bIns="18288" anchor="t">
+            <a:normAutofit/>
           </a:bodyPr>
           <a:lstStyle/>
           <a:p>
             <a:r>
-              <a:rPr sz="1400" b="0">
+              <a:rPr sz="1200" b="0">
                 <a:solidFill>
                   <a:srgbClr val="495461"/>
                 </a:solidFill>
@@ -7782,7 +7782,7 @@
         </p:nvSpPr>
         <p:spPr>
           <a:xfrm>
-            <a:off x="731520" y="1956816"/>
+            <a:off x="731520" y="2048256"/>
             <a:ext cx="100584" cy="100584"/>
           </a:xfrm>
           <a:prstGeom prst="ellipse">
@@ -7825,8 +7825,8 @@
         </p:nvSpPr>
         <p:spPr>
           <a:xfrm>
-            <a:off x="960120" y="1856232"/>
-            <a:ext cx="4754880" cy="530352"/>
+            <a:off x="960120" y="1947672"/>
+            <a:ext cx="4846320" cy="658368"/>
           </a:xfrm>
           <a:prstGeom prst="rect">
             <a:avLst/>
@@ -7834,13 +7834,13 @@
           <a:noFill/>
         </p:spPr>
         <p:txBody>
-          <a:bodyPr wrap="none" lIns="27432" rIns="27432" tIns="18288" bIns="18288" anchor="t">
-            <a:spAutoFit/>
+          <a:bodyPr wrap="square" lIns="27432" rIns="27432" tIns="18288" bIns="18288" anchor="t">
+            <a:normAutofit/>
           </a:bodyPr>
           <a:lstStyle/>
           <a:p>
             <a:r>
-              <a:rPr sz="1400" b="0">
+              <a:rPr sz="1200" b="0">
                 <a:solidFill>
                   <a:srgbClr val="495461"/>
                 </a:solidFill>
@@ -7859,7 +7859,7 @@
         </p:nvSpPr>
         <p:spPr>
           <a:xfrm>
-            <a:off x="731520" y="2578608"/>
+            <a:off x="731520" y="2852928"/>
             <a:ext cx="100584" cy="100584"/>
           </a:xfrm>
           <a:prstGeom prst="ellipse">
@@ -7902,8 +7902,8 @@
         </p:nvSpPr>
         <p:spPr>
           <a:xfrm>
-            <a:off x="960120" y="2478024"/>
-            <a:ext cx="4754880" cy="530352"/>
+            <a:off x="960120" y="2752344"/>
+            <a:ext cx="4846320" cy="658368"/>
           </a:xfrm>
           <a:prstGeom prst="rect">
             <a:avLst/>
@@ -7911,13 +7911,13 @@
           <a:noFill/>
         </p:spPr>
         <p:txBody>
-          <a:bodyPr wrap="none" lIns="27432" rIns="27432" tIns="18288" bIns="18288" anchor="t">
-            <a:spAutoFit/>
+          <a:bodyPr wrap="square" lIns="27432" rIns="27432" tIns="18288" bIns="18288" anchor="t">
+            <a:normAutofit/>
           </a:bodyPr>
           <a:lstStyle/>
           <a:p>
             <a:r>
-              <a:rPr sz="1400" b="0">
+              <a:rPr sz="1200" b="0">
                 <a:solidFill>
                   <a:srgbClr val="495461"/>
                 </a:solidFill>
@@ -7945,8 +7945,8 @@
           <a:noFill/>
         </p:spPr>
         <p:txBody>
-          <a:bodyPr wrap="none" lIns="27432" rIns="27432" tIns="18288" bIns="18288" anchor="t">
-            <a:spAutoFit/>
+          <a:bodyPr wrap="square" lIns="27432" rIns="27432" tIns="18288" bIns="18288" anchor="t">
+            <a:normAutofit/>
           </a:bodyPr>
           <a:lstStyle/>
           <a:p>

</xml_diff>